<commit_message>
Add enlarged PPTX and Word documents with 17.5% scaled diagram
Agent-Logs-Url: https://github.com/leng-peng/new-jet/sessions/e608f0b3-666e-4c03-8915-4b1ce2bcd144

Co-authored-by: leng-peng <252009236+leng-peng@users.noreply.github.com>
</commit_message>
<xml_diff>
--- a/原理图_可编辑版_放大版.pptx
+++ b/原理图_可编辑版_放大版.pptx
@@ -7,7 +7,7 @@
   <p:sldIdLst>
     <p:sldId id="256" r:id="rId7"/>
   </p:sldIdLst>
-  <p:sldSz cx="18000000" cy="41400000" type="screen4x3"/>
+  <p:sldSz cx="21150000" cy="48645000" type="screen4x3"/>
   <p:notesSz cx="6858000" cy="9144000"/>
   <p:defaultTextStyle>
     <a:defPPr>
@@ -3096,8 +3096,8 @@
         </p:nvSpPr>
         <p:spPr>
           <a:xfrm>
-            <a:off x="180000" y="360000"/>
-            <a:ext cx="17640000" cy="1620000"/>
+            <a:off x="211500" y="423000"/>
+            <a:ext cx="20727000" cy="1903500"/>
           </a:xfrm>
           <a:prstGeom prst="roundRect">
             <a:avLst>
@@ -3107,7 +3107,7 @@
           <a:solidFill>
             <a:srgbClr val="D6EAF8"/>
           </a:solidFill>
-          <a:ln w="31750">
+          <a:ln w="37306">
             <a:solidFill>
               <a:srgbClr val="2C3E50"/>
             </a:solidFill>
@@ -3133,14 +3133,14 @@
           <a:p>
             <a:pPr algn="ctr">
               <a:spcBef>
-                <a:spcPts val="200"/>
-              </a:spcBef>
-              <a:spcAft>
-                <a:spcPts val="200"/>
-              </a:spcAft>
-            </a:pPr>
-            <a:r>
-              <a:rPr sz="2600" b="1">
+                <a:spcPts val="235"/>
+              </a:spcBef>
+              <a:spcAft>
+                <a:spcPts val="235"/>
+              </a:spcAft>
+            </a:pPr>
+            <a:r>
+              <a:rPr sz="3055" b="1">
                 <a:solidFill>
                   <a:srgbClr val="1A5C8C"/>
                 </a:solidFill>
@@ -3158,8 +3158,8 @@
         </p:nvSpPr>
         <p:spPr>
           <a:xfrm>
-            <a:off x="360000" y="2340000"/>
-            <a:ext cx="5220000" cy="720000"/>
+            <a:off x="423000" y="2749500"/>
+            <a:ext cx="6133500" cy="846000"/>
           </a:xfrm>
           <a:prstGeom prst="roundRect">
             <a:avLst>
@@ -3169,7 +3169,7 @@
           <a:solidFill>
             <a:srgbClr val="EAF2FF"/>
           </a:solidFill>
-          <a:ln w="19050">
+          <a:ln w="22384">
             <a:solidFill>
               <a:srgbClr val="2C3E50"/>
             </a:solidFill>
@@ -3195,14 +3195,14 @@
           <a:p>
             <a:pPr algn="ctr">
               <a:spcBef>
-                <a:spcPts val="200"/>
-              </a:spcBef>
-              <a:spcAft>
-                <a:spcPts val="200"/>
-              </a:spcAft>
-            </a:pPr>
-            <a:r>
-              <a:rPr sz="1800" b="1">
+                <a:spcPts val="235"/>
+              </a:spcBef>
+              <a:spcAft>
+                <a:spcPts val="235"/>
+              </a:spcAft>
+            </a:pPr>
+            <a:r>
+              <a:rPr sz="2115" b="1">
                 <a:solidFill>
                   <a:srgbClr val="1A5C8C"/>
                 </a:solidFill>
@@ -3220,8 +3220,8 @@
         </p:nvSpPr>
         <p:spPr>
           <a:xfrm>
-            <a:off x="6300000" y="2340000"/>
-            <a:ext cx="6480000" cy="720000"/>
+            <a:off x="7402500" y="2749500"/>
+            <a:ext cx="7614000" cy="846000"/>
           </a:xfrm>
           <a:prstGeom prst="roundRect">
             <a:avLst>
@@ -3231,7 +3231,7 @@
           <a:solidFill>
             <a:srgbClr val="EAF2FF"/>
           </a:solidFill>
-          <a:ln w="19050">
+          <a:ln w="22384">
             <a:solidFill>
               <a:srgbClr val="2C3E50"/>
             </a:solidFill>
@@ -3257,14 +3257,14 @@
           <a:p>
             <a:pPr algn="ctr">
               <a:spcBef>
-                <a:spcPts val="200"/>
-              </a:spcBef>
-              <a:spcAft>
-                <a:spcPts val="200"/>
-              </a:spcAft>
-            </a:pPr>
-            <a:r>
-              <a:rPr sz="1800" b="1">
+                <a:spcPts val="235"/>
+              </a:spcBef>
+              <a:spcAft>
+                <a:spcPts val="235"/>
+              </a:spcAft>
+            </a:pPr>
+            <a:r>
+              <a:rPr sz="2115" b="1">
                 <a:solidFill>
                   <a:srgbClr val="1A5C8C"/>
                 </a:solidFill>
@@ -3282,8 +3282,8 @@
         </p:nvSpPr>
         <p:spPr>
           <a:xfrm>
-            <a:off x="13500000" y="2340000"/>
-            <a:ext cx="3780000" cy="720000"/>
+            <a:off x="15862500" y="2749500"/>
+            <a:ext cx="4441500" cy="846000"/>
           </a:xfrm>
           <a:prstGeom prst="roundRect">
             <a:avLst>
@@ -3293,7 +3293,7 @@
           <a:solidFill>
             <a:srgbClr val="EAF2FF"/>
           </a:solidFill>
-          <a:ln w="19050">
+          <a:ln w="22384">
             <a:solidFill>
               <a:srgbClr val="2C3E50"/>
             </a:solidFill>
@@ -3319,14 +3319,14 @@
           <a:p>
             <a:pPr algn="ctr">
               <a:spcBef>
-                <a:spcPts val="200"/>
-              </a:spcBef>
-              <a:spcAft>
-                <a:spcPts val="200"/>
-              </a:spcAft>
-            </a:pPr>
-            <a:r>
-              <a:rPr sz="1800" b="1">
+                <a:spcPts val="235"/>
+              </a:spcBef>
+              <a:spcAft>
+                <a:spcPts val="235"/>
+              </a:spcAft>
+            </a:pPr>
+            <a:r>
+              <a:rPr sz="2115" b="1">
                 <a:solidFill>
                   <a:srgbClr val="1A5C8C"/>
                 </a:solidFill>
@@ -3344,8 +3344,8 @@
         </p:nvSpPr>
         <p:spPr>
           <a:xfrm>
-            <a:off x="360000" y="3420000"/>
-            <a:ext cx="5220000" cy="1980000"/>
+            <a:off x="423000" y="4018500"/>
+            <a:ext cx="6133500" cy="2326500"/>
           </a:xfrm>
           <a:prstGeom prst="roundRect">
             <a:avLst>
@@ -3355,7 +3355,7 @@
           <a:solidFill>
             <a:srgbClr val="D6EAF8"/>
           </a:solidFill>
-          <a:ln w="19050">
+          <a:ln w="22384">
             <a:solidFill>
               <a:srgbClr val="2C3E50"/>
             </a:solidFill>
@@ -3381,14 +3381,14 @@
           <a:p>
             <a:pPr algn="ctr">
               <a:spcBef>
-                <a:spcPts val="200"/>
-              </a:spcBef>
-              <a:spcAft>
-                <a:spcPts val="200"/>
-              </a:spcAft>
-            </a:pPr>
-            <a:r>
-              <a:rPr sz="1600" b="0">
+                <a:spcPts val="235"/>
+              </a:spcBef>
+              <a:spcAft>
+                <a:spcPts val="235"/>
+              </a:spcAft>
+            </a:pPr>
+            <a:r>
+              <a:rPr sz="1880" b="0">
                 <a:solidFill>
                   <a:srgbClr val="000000"/>
                 </a:solidFill>
@@ -3399,14 +3399,14 @@
           <a:p>
             <a:pPr algn="ctr">
               <a:spcBef>
-                <a:spcPts val="200"/>
-              </a:spcBef>
-              <a:spcAft>
-                <a:spcPts val="200"/>
-              </a:spcAft>
-            </a:pPr>
-            <a:r>
-              <a:rPr sz="1600" b="0">
+                <a:spcPts val="235"/>
+              </a:spcBef>
+              <a:spcAft>
+                <a:spcPts val="235"/>
+              </a:spcAft>
+            </a:pPr>
+            <a:r>
+              <a:rPr sz="1880" b="0">
                 <a:solidFill>
                   <a:srgbClr val="000000"/>
                 </a:solidFill>
@@ -3417,14 +3417,14 @@
           <a:p>
             <a:pPr algn="ctr">
               <a:spcBef>
-                <a:spcPts val="200"/>
-              </a:spcBef>
-              <a:spcAft>
-                <a:spcPts val="200"/>
-              </a:spcAft>
-            </a:pPr>
-            <a:r>
-              <a:rPr sz="1600" b="0">
+                <a:spcPts val="235"/>
+              </a:spcBef>
+              <a:spcAft>
+                <a:spcPts val="235"/>
+              </a:spcAft>
+            </a:pPr>
+            <a:r>
+              <a:rPr sz="1880" b="0">
                 <a:solidFill>
                   <a:srgbClr val="000000"/>
                 </a:solidFill>
@@ -3442,8 +3442,8 @@
         </p:nvSpPr>
         <p:spPr>
           <a:xfrm>
-            <a:off x="360000" y="5688000"/>
-            <a:ext cx="5220000" cy="1980000"/>
+            <a:off x="423000" y="6683400"/>
+            <a:ext cx="6133500" cy="2326500"/>
           </a:xfrm>
           <a:prstGeom prst="roundRect">
             <a:avLst>
@@ -3453,7 +3453,7 @@
           <a:solidFill>
             <a:srgbClr val="D6EAF8"/>
           </a:solidFill>
-          <a:ln w="19050">
+          <a:ln w="22384">
             <a:solidFill>
               <a:srgbClr val="2C3E50"/>
             </a:solidFill>
@@ -3479,14 +3479,14 @@
           <a:p>
             <a:pPr algn="ctr">
               <a:spcBef>
-                <a:spcPts val="200"/>
-              </a:spcBef>
-              <a:spcAft>
-                <a:spcPts val="200"/>
-              </a:spcAft>
-            </a:pPr>
-            <a:r>
-              <a:rPr sz="1600" b="0">
+                <a:spcPts val="235"/>
+              </a:spcBef>
+              <a:spcAft>
+                <a:spcPts val="235"/>
+              </a:spcAft>
+            </a:pPr>
+            <a:r>
+              <a:rPr sz="1880" b="0">
                 <a:solidFill>
                   <a:srgbClr val="000000"/>
                 </a:solidFill>
@@ -3497,14 +3497,14 @@
           <a:p>
             <a:pPr algn="ctr">
               <a:spcBef>
-                <a:spcPts val="200"/>
-              </a:spcBef>
-              <a:spcAft>
-                <a:spcPts val="200"/>
-              </a:spcAft>
-            </a:pPr>
-            <a:r>
-              <a:rPr sz="1600" b="0">
+                <a:spcPts val="235"/>
+              </a:spcBef>
+              <a:spcAft>
+                <a:spcPts val="235"/>
+              </a:spcAft>
+            </a:pPr>
+            <a:r>
+              <a:rPr sz="1880" b="0">
                 <a:solidFill>
                   <a:srgbClr val="000000"/>
                 </a:solidFill>
@@ -3515,14 +3515,14 @@
           <a:p>
             <a:pPr algn="ctr">
               <a:spcBef>
-                <a:spcPts val="200"/>
-              </a:spcBef>
-              <a:spcAft>
-                <a:spcPts val="200"/>
-              </a:spcAft>
-            </a:pPr>
-            <a:r>
-              <a:rPr sz="1600" b="0">
+                <a:spcPts val="235"/>
+              </a:spcBef>
+              <a:spcAft>
+                <a:spcPts val="235"/>
+              </a:spcAft>
+            </a:pPr>
+            <a:r>
+              <a:rPr sz="1880" b="0">
                 <a:solidFill>
                   <a:srgbClr val="000000"/>
                 </a:solidFill>
@@ -3540,8 +3540,8 @@
         </p:nvSpPr>
         <p:spPr>
           <a:xfrm>
-            <a:off x="360000" y="7956000"/>
-            <a:ext cx="5220000" cy="2160000"/>
+            <a:off x="423000" y="9348300"/>
+            <a:ext cx="6133500" cy="2538000"/>
           </a:xfrm>
           <a:prstGeom prst="roundRect">
             <a:avLst>
@@ -3551,7 +3551,7 @@
           <a:solidFill>
             <a:srgbClr val="D6EAF8"/>
           </a:solidFill>
-          <a:ln w="19050">
+          <a:ln w="22384">
             <a:solidFill>
               <a:srgbClr val="2C3E50"/>
             </a:solidFill>
@@ -3577,14 +3577,14 @@
           <a:p>
             <a:pPr algn="ctr">
               <a:spcBef>
-                <a:spcPts val="200"/>
-              </a:spcBef>
-              <a:spcAft>
-                <a:spcPts val="200"/>
-              </a:spcAft>
-            </a:pPr>
-            <a:r>
-              <a:rPr sz="1600" b="0">
+                <a:spcPts val="235"/>
+              </a:spcBef>
+              <a:spcAft>
+                <a:spcPts val="235"/>
+              </a:spcAft>
+            </a:pPr>
+            <a:r>
+              <a:rPr sz="1880" b="0">
                 <a:solidFill>
                   <a:srgbClr val="000000"/>
                 </a:solidFill>
@@ -3595,14 +3595,14 @@
           <a:p>
             <a:pPr algn="ctr">
               <a:spcBef>
-                <a:spcPts val="200"/>
-              </a:spcBef>
-              <a:spcAft>
-                <a:spcPts val="200"/>
-              </a:spcAft>
-            </a:pPr>
-            <a:r>
-              <a:rPr sz="1600" b="0">
+                <a:spcPts val="235"/>
+              </a:spcBef>
+              <a:spcAft>
+                <a:spcPts val="235"/>
+              </a:spcAft>
+            </a:pPr>
+            <a:r>
+              <a:rPr sz="1880" b="0">
                 <a:solidFill>
                   <a:srgbClr val="000000"/>
                 </a:solidFill>
@@ -3613,14 +3613,14 @@
           <a:p>
             <a:pPr algn="ctr">
               <a:spcBef>
-                <a:spcPts val="200"/>
-              </a:spcBef>
-              <a:spcAft>
-                <a:spcPts val="200"/>
-              </a:spcAft>
-            </a:pPr>
-            <a:r>
-              <a:rPr sz="1600" b="0">
+                <a:spcPts val="235"/>
+              </a:spcBef>
+              <a:spcAft>
+                <a:spcPts val="235"/>
+              </a:spcAft>
+            </a:pPr>
+            <a:r>
+              <a:rPr sz="1880" b="0">
                 <a:solidFill>
                   <a:srgbClr val="000000"/>
                 </a:solidFill>
@@ -3631,14 +3631,14 @@
           <a:p>
             <a:pPr algn="ctr">
               <a:spcBef>
-                <a:spcPts val="200"/>
-              </a:spcBef>
-              <a:spcAft>
-                <a:spcPts val="200"/>
-              </a:spcAft>
-            </a:pPr>
-            <a:r>
-              <a:rPr sz="1600" b="0">
+                <a:spcPts val="235"/>
+              </a:spcBef>
+              <a:spcAft>
+                <a:spcPts val="235"/>
+              </a:spcAft>
+            </a:pPr>
+            <a:r>
+              <a:rPr sz="1880" b="0">
                 <a:solidFill>
                   <a:srgbClr val="000000"/>
                 </a:solidFill>
@@ -3656,8 +3656,8 @@
         </p:nvSpPr>
         <p:spPr>
           <a:xfrm>
-            <a:off x="360000" y="10404000"/>
-            <a:ext cx="5220000" cy="1980000"/>
+            <a:off x="423000" y="12224700"/>
+            <a:ext cx="6133500" cy="2326500"/>
           </a:xfrm>
           <a:prstGeom prst="roundRect">
             <a:avLst>
@@ -3667,7 +3667,7 @@
           <a:solidFill>
             <a:srgbClr val="D6EAF8"/>
           </a:solidFill>
-          <a:ln w="19050">
+          <a:ln w="22384">
             <a:solidFill>
               <a:srgbClr val="2C3E50"/>
             </a:solidFill>
@@ -3693,14 +3693,14 @@
           <a:p>
             <a:pPr algn="ctr">
               <a:spcBef>
-                <a:spcPts val="200"/>
-              </a:spcBef>
-              <a:spcAft>
-                <a:spcPts val="200"/>
-              </a:spcAft>
-            </a:pPr>
-            <a:r>
-              <a:rPr sz="1600" b="0">
+                <a:spcPts val="235"/>
+              </a:spcBef>
+              <a:spcAft>
+                <a:spcPts val="235"/>
+              </a:spcAft>
+            </a:pPr>
+            <a:r>
+              <a:rPr sz="1880" b="0">
                 <a:solidFill>
                   <a:srgbClr val="000000"/>
                 </a:solidFill>
@@ -3711,14 +3711,14 @@
           <a:p>
             <a:pPr algn="ctr">
               <a:spcBef>
-                <a:spcPts val="200"/>
-              </a:spcBef>
-              <a:spcAft>
-                <a:spcPts val="200"/>
-              </a:spcAft>
-            </a:pPr>
-            <a:r>
-              <a:rPr sz="1600" b="0">
+                <a:spcPts val="235"/>
+              </a:spcBef>
+              <a:spcAft>
+                <a:spcPts val="235"/>
+              </a:spcAft>
+            </a:pPr>
+            <a:r>
+              <a:rPr sz="1880" b="0">
                 <a:solidFill>
                   <a:srgbClr val="000000"/>
                 </a:solidFill>
@@ -3729,14 +3729,14 @@
           <a:p>
             <a:pPr algn="ctr">
               <a:spcBef>
-                <a:spcPts val="200"/>
-              </a:spcBef>
-              <a:spcAft>
-                <a:spcPts val="200"/>
-              </a:spcAft>
-            </a:pPr>
-            <a:r>
-              <a:rPr sz="1600" b="0">
+                <a:spcPts val="235"/>
+              </a:spcBef>
+              <a:spcAft>
+                <a:spcPts val="235"/>
+              </a:spcAft>
+            </a:pPr>
+            <a:r>
+              <a:rPr sz="1880" b="0">
                 <a:solidFill>
                   <a:srgbClr val="000000"/>
                 </a:solidFill>
@@ -3754,8 +3754,8 @@
         </p:nvSpPr>
         <p:spPr>
           <a:xfrm>
-            <a:off x="360000" y="12672000"/>
-            <a:ext cx="5220000" cy="1980000"/>
+            <a:off x="423000" y="14889600"/>
+            <a:ext cx="6133500" cy="2326500"/>
           </a:xfrm>
           <a:prstGeom prst="roundRect">
             <a:avLst>
@@ -3765,7 +3765,7 @@
           <a:solidFill>
             <a:srgbClr val="D6EAF8"/>
           </a:solidFill>
-          <a:ln w="19050">
+          <a:ln w="22384">
             <a:solidFill>
               <a:srgbClr val="2C3E50"/>
             </a:solidFill>
@@ -3791,14 +3791,14 @@
           <a:p>
             <a:pPr algn="ctr">
               <a:spcBef>
-                <a:spcPts val="200"/>
-              </a:spcBef>
-              <a:spcAft>
-                <a:spcPts val="200"/>
-              </a:spcAft>
-            </a:pPr>
-            <a:r>
-              <a:rPr sz="1600" b="0">
+                <a:spcPts val="235"/>
+              </a:spcBef>
+              <a:spcAft>
+                <a:spcPts val="235"/>
+              </a:spcAft>
+            </a:pPr>
+            <a:r>
+              <a:rPr sz="1880" b="0">
                 <a:solidFill>
                   <a:srgbClr val="000000"/>
                 </a:solidFill>
@@ -3809,14 +3809,14 @@
           <a:p>
             <a:pPr algn="ctr">
               <a:spcBef>
-                <a:spcPts val="200"/>
-              </a:spcBef>
-              <a:spcAft>
-                <a:spcPts val="200"/>
-              </a:spcAft>
-            </a:pPr>
-            <a:r>
-              <a:rPr sz="1600" b="0">
+                <a:spcPts val="235"/>
+              </a:spcBef>
+              <a:spcAft>
+                <a:spcPts val="235"/>
+              </a:spcAft>
+            </a:pPr>
+            <a:r>
+              <a:rPr sz="1880" b="0">
                 <a:solidFill>
                   <a:srgbClr val="000000"/>
                 </a:solidFill>
@@ -3827,14 +3827,14 @@
           <a:p>
             <a:pPr algn="ctr">
               <a:spcBef>
-                <a:spcPts val="200"/>
-              </a:spcBef>
-              <a:spcAft>
-                <a:spcPts val="200"/>
-              </a:spcAft>
-            </a:pPr>
-            <a:r>
-              <a:rPr sz="1600" b="0">
+                <a:spcPts val="235"/>
+              </a:spcBef>
+              <a:spcAft>
+                <a:spcPts val="235"/>
+              </a:spcAft>
+            </a:pPr>
+            <a:r>
+              <a:rPr sz="1880" b="0">
                 <a:solidFill>
                   <a:srgbClr val="000000"/>
                 </a:solidFill>
@@ -3852,8 +3852,8 @@
         </p:nvSpPr>
         <p:spPr>
           <a:xfrm>
-            <a:off x="360000" y="14940000"/>
-            <a:ext cx="5220000" cy="2160000"/>
+            <a:off x="423000" y="17554500"/>
+            <a:ext cx="6133500" cy="2538000"/>
           </a:xfrm>
           <a:prstGeom prst="roundRect">
             <a:avLst>
@@ -3863,7 +3863,7 @@
           <a:solidFill>
             <a:srgbClr val="FDEDEC"/>
           </a:solidFill>
-          <a:ln w="19050">
+          <a:ln w="22384">
             <a:solidFill>
               <a:srgbClr val="2C3E50"/>
             </a:solidFill>
@@ -3889,14 +3889,14 @@
           <a:p>
             <a:pPr algn="ctr">
               <a:spcBef>
-                <a:spcPts val="200"/>
-              </a:spcBef>
-              <a:spcAft>
-                <a:spcPts val="200"/>
-              </a:spcAft>
-            </a:pPr>
-            <a:r>
-              <a:rPr sz="1600" b="0">
+                <a:spcPts val="235"/>
+              </a:spcBef>
+              <a:spcAft>
+                <a:spcPts val="235"/>
+              </a:spcAft>
+            </a:pPr>
+            <a:r>
+              <a:rPr sz="1880" b="0">
                 <a:solidFill>
                   <a:srgbClr val="000000"/>
                 </a:solidFill>
@@ -3907,14 +3907,14 @@
           <a:p>
             <a:pPr algn="ctr">
               <a:spcBef>
-                <a:spcPts val="200"/>
-              </a:spcBef>
-              <a:spcAft>
-                <a:spcPts val="200"/>
-              </a:spcAft>
-            </a:pPr>
-            <a:r>
-              <a:rPr sz="1600" b="0">
+                <a:spcPts val="235"/>
+              </a:spcBef>
+              <a:spcAft>
+                <a:spcPts val="235"/>
+              </a:spcAft>
+            </a:pPr>
+            <a:r>
+              <a:rPr sz="1880" b="0">
                 <a:solidFill>
                   <a:srgbClr val="000000"/>
                 </a:solidFill>
@@ -3925,14 +3925,14 @@
           <a:p>
             <a:pPr algn="ctr">
               <a:spcBef>
-                <a:spcPts val="200"/>
-              </a:spcBef>
-              <a:spcAft>
-                <a:spcPts val="200"/>
-              </a:spcAft>
-            </a:pPr>
-            <a:r>
-              <a:rPr sz="1600" b="0">
+                <a:spcPts val="235"/>
+              </a:spcBef>
+              <a:spcAft>
+                <a:spcPts val="235"/>
+              </a:spcAft>
+            </a:pPr>
+            <a:r>
+              <a:rPr sz="1880" b="0">
                 <a:solidFill>
                   <a:srgbClr val="000000"/>
                 </a:solidFill>
@@ -3943,14 +3943,14 @@
           <a:p>
             <a:pPr algn="ctr">
               <a:spcBef>
-                <a:spcPts val="200"/>
-              </a:spcBef>
-              <a:spcAft>
-                <a:spcPts val="200"/>
-              </a:spcAft>
-            </a:pPr>
-            <a:r>
-              <a:rPr sz="1600" b="0">
+                <a:spcPts val="235"/>
+              </a:spcBef>
+              <a:spcAft>
+                <a:spcPts val="235"/>
+              </a:spcAft>
+            </a:pPr>
+            <a:r>
+              <a:rPr sz="1880" b="0">
                 <a:solidFill>
                   <a:srgbClr val="000000"/>
                 </a:solidFill>
@@ -3968,8 +3968,8 @@
         </p:nvSpPr>
         <p:spPr>
           <a:xfrm>
-            <a:off x="360000" y="17388000"/>
-            <a:ext cx="5220000" cy="1980000"/>
+            <a:off x="423000" y="20430900"/>
+            <a:ext cx="6133500" cy="2326500"/>
           </a:xfrm>
           <a:prstGeom prst="roundRect">
             <a:avLst>
@@ -3979,7 +3979,7 @@
           <a:solidFill>
             <a:srgbClr val="D6EAF8"/>
           </a:solidFill>
-          <a:ln w="19050">
+          <a:ln w="22384">
             <a:solidFill>
               <a:srgbClr val="2C3E50"/>
             </a:solidFill>
@@ -4005,14 +4005,14 @@
           <a:p>
             <a:pPr algn="ctr">
               <a:spcBef>
-                <a:spcPts val="200"/>
-              </a:spcBef>
-              <a:spcAft>
-                <a:spcPts val="200"/>
-              </a:spcAft>
-            </a:pPr>
-            <a:r>
-              <a:rPr sz="1600" b="0">
+                <a:spcPts val="235"/>
+              </a:spcBef>
+              <a:spcAft>
+                <a:spcPts val="235"/>
+              </a:spcAft>
+            </a:pPr>
+            <a:r>
+              <a:rPr sz="1880" b="0">
                 <a:solidFill>
                   <a:srgbClr val="000000"/>
                 </a:solidFill>
@@ -4023,14 +4023,14 @@
           <a:p>
             <a:pPr algn="ctr">
               <a:spcBef>
-                <a:spcPts val="200"/>
-              </a:spcBef>
-              <a:spcAft>
-                <a:spcPts val="200"/>
-              </a:spcAft>
-            </a:pPr>
-            <a:r>
-              <a:rPr sz="1600" b="0">
+                <a:spcPts val="235"/>
+              </a:spcBef>
+              <a:spcAft>
+                <a:spcPts val="235"/>
+              </a:spcAft>
+            </a:pPr>
+            <a:r>
+              <a:rPr sz="1880" b="0">
                 <a:solidFill>
                   <a:srgbClr val="000000"/>
                 </a:solidFill>
@@ -4041,14 +4041,14 @@
           <a:p>
             <a:pPr algn="ctr">
               <a:spcBef>
-                <a:spcPts val="200"/>
-              </a:spcBef>
-              <a:spcAft>
-                <a:spcPts val="200"/>
-              </a:spcAft>
-            </a:pPr>
-            <a:r>
-              <a:rPr sz="1600" b="0">
+                <a:spcPts val="235"/>
+              </a:spcBef>
+              <a:spcAft>
+                <a:spcPts val="235"/>
+              </a:spcAft>
+            </a:pPr>
+            <a:r>
+              <a:rPr sz="1880" b="0">
                 <a:solidFill>
                   <a:srgbClr val="000000"/>
                 </a:solidFill>
@@ -4066,8 +4066,8 @@
         </p:nvSpPr>
         <p:spPr>
           <a:xfrm>
-            <a:off x="6300000" y="3420000"/>
-            <a:ext cx="6480000" cy="2700000"/>
+            <a:off x="7402500" y="4018500"/>
+            <a:ext cx="7614000" cy="3172500"/>
           </a:xfrm>
           <a:prstGeom prst="roundRect">
             <a:avLst>
@@ -4077,7 +4077,7 @@
           <a:solidFill>
             <a:srgbClr val="D5F5E3"/>
           </a:solidFill>
-          <a:ln w="19050">
+          <a:ln w="22384">
             <a:solidFill>
               <a:srgbClr val="2C3E50"/>
             </a:solidFill>
@@ -4103,14 +4103,14 @@
           <a:p>
             <a:pPr algn="ctr">
               <a:spcBef>
-                <a:spcPts val="200"/>
-              </a:spcBef>
-              <a:spcAft>
-                <a:spcPts val="200"/>
-              </a:spcAft>
-            </a:pPr>
-            <a:r>
-              <a:rPr sz="1600" b="0">
+                <a:spcPts val="235"/>
+              </a:spcBef>
+              <a:spcAft>
+                <a:spcPts val="235"/>
+              </a:spcAft>
+            </a:pPr>
+            <a:r>
+              <a:rPr sz="1880" b="0">
                 <a:solidFill>
                   <a:srgbClr val="000000"/>
                 </a:solidFill>
@@ -4121,14 +4121,14 @@
           <a:p>
             <a:pPr algn="ctr">
               <a:spcBef>
-                <a:spcPts val="200"/>
-              </a:spcBef>
-              <a:spcAft>
-                <a:spcPts val="200"/>
-              </a:spcAft>
-            </a:pPr>
-            <a:r>
-              <a:rPr sz="1600" b="0">
+                <a:spcPts val="235"/>
+              </a:spcBef>
+              <a:spcAft>
+                <a:spcPts val="235"/>
+              </a:spcAft>
+            </a:pPr>
+            <a:r>
+              <a:rPr sz="1880" b="0">
                 <a:solidFill>
                   <a:srgbClr val="000000"/>
                 </a:solidFill>
@@ -4139,14 +4139,14 @@
           <a:p>
             <a:pPr algn="ctr">
               <a:spcBef>
-                <a:spcPts val="200"/>
-              </a:spcBef>
-              <a:spcAft>
-                <a:spcPts val="200"/>
-              </a:spcAft>
-            </a:pPr>
-            <a:r>
-              <a:rPr sz="1600" b="0">
+                <a:spcPts val="235"/>
+              </a:spcBef>
+              <a:spcAft>
+                <a:spcPts val="235"/>
+              </a:spcAft>
+            </a:pPr>
+            <a:r>
+              <a:rPr sz="1880" b="0">
                 <a:solidFill>
                   <a:srgbClr val="000000"/>
                 </a:solidFill>
@@ -4157,14 +4157,14 @@
           <a:p>
             <a:pPr algn="ctr">
               <a:spcBef>
-                <a:spcPts val="200"/>
-              </a:spcBef>
-              <a:spcAft>
-                <a:spcPts val="200"/>
-              </a:spcAft>
-            </a:pPr>
-            <a:r>
-              <a:rPr sz="1600" b="0">
+                <a:spcPts val="235"/>
+              </a:spcBef>
+              <a:spcAft>
+                <a:spcPts val="235"/>
+              </a:spcAft>
+            </a:pPr>
+            <a:r>
+              <a:rPr sz="1880" b="0">
                 <a:solidFill>
                   <a:srgbClr val="000000"/>
                 </a:solidFill>
@@ -4175,14 +4175,14 @@
           <a:p>
             <a:pPr algn="ctr">
               <a:spcBef>
-                <a:spcPts val="200"/>
-              </a:spcBef>
-              <a:spcAft>
-                <a:spcPts val="200"/>
-              </a:spcAft>
-            </a:pPr>
-            <a:r>
-              <a:rPr sz="1600" b="0">
+                <a:spcPts val="235"/>
+              </a:spcBef>
+              <a:spcAft>
+                <a:spcPts val="235"/>
+              </a:spcAft>
+            </a:pPr>
+            <a:r>
+              <a:rPr sz="1880" b="0">
                 <a:solidFill>
                   <a:srgbClr val="000000"/>
                 </a:solidFill>
@@ -4200,8 +4200,8 @@
         </p:nvSpPr>
         <p:spPr>
           <a:xfrm>
-            <a:off x="6300000" y="6552000"/>
-            <a:ext cx="6480000" cy="3960000"/>
+            <a:off x="7402500" y="7698600"/>
+            <a:ext cx="7614000" cy="4653000"/>
           </a:xfrm>
           <a:prstGeom prst="roundRect">
             <a:avLst>
@@ -4211,7 +4211,7 @@
           <a:solidFill>
             <a:srgbClr val="FDEBD0"/>
           </a:solidFill>
-          <a:ln w="19050">
+          <a:ln w="22384">
             <a:solidFill>
               <a:srgbClr val="2C3E50"/>
             </a:solidFill>
@@ -4237,14 +4237,14 @@
           <a:p>
             <a:pPr algn="ctr">
               <a:spcBef>
-                <a:spcPts val="200"/>
-              </a:spcBef>
-              <a:spcAft>
-                <a:spcPts val="200"/>
-              </a:spcAft>
-            </a:pPr>
-            <a:r>
-              <a:rPr sz="1600" b="0">
+                <a:spcPts val="235"/>
+              </a:spcBef>
+              <a:spcAft>
+                <a:spcPts val="235"/>
+              </a:spcAft>
+            </a:pPr>
+            <a:r>
+              <a:rPr sz="1880" b="0">
                 <a:solidFill>
                   <a:srgbClr val="000000"/>
                 </a:solidFill>
@@ -4255,14 +4255,14 @@
           <a:p>
             <a:pPr algn="ctr">
               <a:spcBef>
-                <a:spcPts val="200"/>
-              </a:spcBef>
-              <a:spcAft>
-                <a:spcPts val="200"/>
-              </a:spcAft>
-            </a:pPr>
-            <a:r>
-              <a:rPr sz="1600" b="0">
+                <a:spcPts val="235"/>
+              </a:spcBef>
+              <a:spcAft>
+                <a:spcPts val="235"/>
+              </a:spcAft>
+            </a:pPr>
+            <a:r>
+              <a:rPr sz="1880" b="0">
                 <a:solidFill>
                   <a:srgbClr val="000000"/>
                 </a:solidFill>
@@ -4273,14 +4273,14 @@
           <a:p>
             <a:pPr algn="ctr">
               <a:spcBef>
-                <a:spcPts val="200"/>
-              </a:spcBef>
-              <a:spcAft>
-                <a:spcPts val="200"/>
-              </a:spcAft>
-            </a:pPr>
-            <a:r>
-              <a:rPr sz="1600" b="0">
+                <a:spcPts val="235"/>
+              </a:spcBef>
+              <a:spcAft>
+                <a:spcPts val="235"/>
+              </a:spcAft>
+            </a:pPr>
+            <a:r>
+              <a:rPr sz="1880" b="0">
                 <a:solidFill>
                   <a:srgbClr val="000000"/>
                 </a:solidFill>
@@ -4291,14 +4291,14 @@
           <a:p>
             <a:pPr algn="ctr">
               <a:spcBef>
-                <a:spcPts val="200"/>
-              </a:spcBef>
-              <a:spcAft>
-                <a:spcPts val="200"/>
-              </a:spcAft>
-            </a:pPr>
-            <a:r>
-              <a:rPr sz="1600" b="0">
+                <a:spcPts val="235"/>
+              </a:spcBef>
+              <a:spcAft>
+                <a:spcPts val="235"/>
+              </a:spcAft>
+            </a:pPr>
+            <a:r>
+              <a:rPr sz="1880" b="0">
                 <a:solidFill>
                   <a:srgbClr val="000000"/>
                 </a:solidFill>
@@ -4309,14 +4309,14 @@
           <a:p>
             <a:pPr algn="ctr">
               <a:spcBef>
-                <a:spcPts val="200"/>
-              </a:spcBef>
-              <a:spcAft>
-                <a:spcPts val="200"/>
-              </a:spcAft>
-            </a:pPr>
-            <a:r>
-              <a:rPr sz="1600" b="0">
+                <a:spcPts val="235"/>
+              </a:spcBef>
+              <a:spcAft>
+                <a:spcPts val="235"/>
+              </a:spcAft>
+            </a:pPr>
+            <a:r>
+              <a:rPr sz="1880" b="0">
                 <a:solidFill>
                   <a:srgbClr val="000000"/>
                 </a:solidFill>
@@ -4327,14 +4327,14 @@
           <a:p>
             <a:pPr algn="ctr">
               <a:spcBef>
-                <a:spcPts val="200"/>
-              </a:spcBef>
-              <a:spcAft>
-                <a:spcPts val="200"/>
-              </a:spcAft>
-            </a:pPr>
-            <a:r>
-              <a:rPr sz="1600" b="0">
+                <a:spcPts val="235"/>
+              </a:spcBef>
+              <a:spcAft>
+                <a:spcPts val="235"/>
+              </a:spcAft>
+            </a:pPr>
+            <a:r>
+              <a:rPr sz="1880" b="0">
                 <a:solidFill>
                   <a:srgbClr val="000000"/>
                 </a:solidFill>
@@ -4345,14 +4345,14 @@
           <a:p>
             <a:pPr algn="ctr">
               <a:spcBef>
-                <a:spcPts val="200"/>
-              </a:spcBef>
-              <a:spcAft>
-                <a:spcPts val="200"/>
-              </a:spcAft>
-            </a:pPr>
-            <a:r>
-              <a:rPr sz="1600" b="0">
+                <a:spcPts val="235"/>
+              </a:spcBef>
+              <a:spcAft>
+                <a:spcPts val="235"/>
+              </a:spcAft>
+            </a:pPr>
+            <a:r>
+              <a:rPr sz="1880" b="0">
                 <a:solidFill>
                   <a:srgbClr val="000000"/>
                 </a:solidFill>
@@ -4363,14 +4363,14 @@
           <a:p>
             <a:pPr algn="ctr">
               <a:spcBef>
-                <a:spcPts val="200"/>
-              </a:spcBef>
-              <a:spcAft>
-                <a:spcPts val="200"/>
-              </a:spcAft>
-            </a:pPr>
-            <a:r>
-              <a:rPr sz="1600" b="0">
+                <a:spcPts val="235"/>
+              </a:spcBef>
+              <a:spcAft>
+                <a:spcPts val="235"/>
+              </a:spcAft>
+            </a:pPr>
+            <a:r>
+              <a:rPr sz="1880" b="0">
                 <a:solidFill>
                   <a:srgbClr val="000000"/>
                 </a:solidFill>
@@ -4388,8 +4388,8 @@
         </p:nvSpPr>
         <p:spPr>
           <a:xfrm>
-            <a:off x="6300000" y="10944000"/>
-            <a:ext cx="6480000" cy="1980000"/>
+            <a:off x="7402500" y="12859200"/>
+            <a:ext cx="7614000" cy="2326500"/>
           </a:xfrm>
           <a:prstGeom prst="roundRect">
             <a:avLst>
@@ -4399,7 +4399,7 @@
           <a:solidFill>
             <a:srgbClr val="FDEBD0"/>
           </a:solidFill>
-          <a:ln w="31750">
+          <a:ln w="37306">
             <a:solidFill>
               <a:srgbClr val="2C3E50"/>
             </a:solidFill>
@@ -4425,14 +4425,14 @@
           <a:p>
             <a:pPr algn="ctr">
               <a:spcBef>
-                <a:spcPts val="200"/>
-              </a:spcBef>
-              <a:spcAft>
-                <a:spcPts val="200"/>
-              </a:spcAft>
-            </a:pPr>
-            <a:r>
-              <a:rPr sz="1600" b="1">
+                <a:spcPts val="235"/>
+              </a:spcBef>
+              <a:spcAft>
+                <a:spcPts val="235"/>
+              </a:spcAft>
+            </a:pPr>
+            <a:r>
+              <a:rPr sz="1880" b="1">
                 <a:solidFill>
                   <a:srgbClr val="000000"/>
                 </a:solidFill>
@@ -4443,14 +4443,14 @@
           <a:p>
             <a:pPr algn="ctr">
               <a:spcBef>
-                <a:spcPts val="200"/>
-              </a:spcBef>
-              <a:spcAft>
-                <a:spcPts val="200"/>
-              </a:spcAft>
-            </a:pPr>
-            <a:r>
-              <a:rPr sz="1600" b="1">
+                <a:spcPts val="235"/>
+              </a:spcBef>
+              <a:spcAft>
+                <a:spcPts val="235"/>
+              </a:spcAft>
+            </a:pPr>
+            <a:r>
+              <a:rPr sz="1880" b="1">
                 <a:solidFill>
                   <a:srgbClr val="000000"/>
                 </a:solidFill>
@@ -4461,14 +4461,14 @@
           <a:p>
             <a:pPr algn="ctr">
               <a:spcBef>
-                <a:spcPts val="200"/>
-              </a:spcBef>
-              <a:spcAft>
-                <a:spcPts val="200"/>
-              </a:spcAft>
-            </a:pPr>
-            <a:r>
-              <a:rPr sz="1600" b="1">
+                <a:spcPts val="235"/>
+              </a:spcBef>
+              <a:spcAft>
+                <a:spcPts val="235"/>
+              </a:spcAft>
+            </a:pPr>
+            <a:r>
+              <a:rPr sz="1880" b="1">
                 <a:solidFill>
                   <a:srgbClr val="000000"/>
                 </a:solidFill>
@@ -4486,8 +4486,8 @@
         </p:nvSpPr>
         <p:spPr>
           <a:xfrm>
-            <a:off x="6300000" y="13356000"/>
-            <a:ext cx="6480000" cy="2160000"/>
+            <a:off x="7402500" y="15693300"/>
+            <a:ext cx="7614000" cy="2538000"/>
           </a:xfrm>
           <a:prstGeom prst="roundRect">
             <a:avLst>
@@ -4497,7 +4497,7 @@
           <a:solidFill>
             <a:srgbClr val="F9EBEA"/>
           </a:solidFill>
-          <a:ln w="19050">
+          <a:ln w="22384">
             <a:solidFill>
               <a:srgbClr val="2C3E50"/>
             </a:solidFill>
@@ -4523,14 +4523,14 @@
           <a:p>
             <a:pPr algn="ctr">
               <a:spcBef>
-                <a:spcPts val="200"/>
-              </a:spcBef>
-              <a:spcAft>
-                <a:spcPts val="200"/>
-              </a:spcAft>
-            </a:pPr>
-            <a:r>
-              <a:rPr sz="1600" b="0">
+                <a:spcPts val="235"/>
+              </a:spcBef>
+              <a:spcAft>
+                <a:spcPts val="235"/>
+              </a:spcAft>
+            </a:pPr>
+            <a:r>
+              <a:rPr sz="1880" b="0">
                 <a:solidFill>
                   <a:srgbClr val="000000"/>
                 </a:solidFill>
@@ -4541,14 +4541,14 @@
           <a:p>
             <a:pPr algn="ctr">
               <a:spcBef>
-                <a:spcPts val="200"/>
-              </a:spcBef>
-              <a:spcAft>
-                <a:spcPts val="200"/>
-              </a:spcAft>
-            </a:pPr>
-            <a:r>
-              <a:rPr sz="1600" b="0">
+                <a:spcPts val="235"/>
+              </a:spcBef>
+              <a:spcAft>
+                <a:spcPts val="235"/>
+              </a:spcAft>
+            </a:pPr>
+            <a:r>
+              <a:rPr sz="1880" b="0">
                 <a:solidFill>
                   <a:srgbClr val="000000"/>
                 </a:solidFill>
@@ -4559,14 +4559,14 @@
           <a:p>
             <a:pPr algn="ctr">
               <a:spcBef>
-                <a:spcPts val="200"/>
-              </a:spcBef>
-              <a:spcAft>
-                <a:spcPts val="200"/>
-              </a:spcAft>
-            </a:pPr>
-            <a:r>
-              <a:rPr sz="1600" b="0">
+                <a:spcPts val="235"/>
+              </a:spcBef>
+              <a:spcAft>
+                <a:spcPts val="235"/>
+              </a:spcAft>
+            </a:pPr>
+            <a:r>
+              <a:rPr sz="1880" b="0">
                 <a:solidFill>
                   <a:srgbClr val="000000"/>
                 </a:solidFill>
@@ -4577,14 +4577,14 @@
           <a:p>
             <a:pPr algn="ctr">
               <a:spcBef>
-                <a:spcPts val="200"/>
-              </a:spcBef>
-              <a:spcAft>
-                <a:spcPts val="200"/>
-              </a:spcAft>
-            </a:pPr>
-            <a:r>
-              <a:rPr sz="1600" b="0">
+                <a:spcPts val="235"/>
+              </a:spcBef>
+              <a:spcAft>
+                <a:spcPts val="235"/>
+              </a:spcAft>
+            </a:pPr>
+            <a:r>
+              <a:rPr sz="1880" b="0">
                 <a:solidFill>
                   <a:srgbClr val="000000"/>
                 </a:solidFill>
@@ -4602,8 +4602,8 @@
         </p:nvSpPr>
         <p:spPr>
           <a:xfrm>
-            <a:off x="6300000" y="15948000"/>
-            <a:ext cx="6480000" cy="2160000"/>
+            <a:off x="7402500" y="18738900"/>
+            <a:ext cx="7614000" cy="2538000"/>
           </a:xfrm>
           <a:prstGeom prst="roundRect">
             <a:avLst>
@@ -4613,7 +4613,7 @@
           <a:solidFill>
             <a:srgbClr val="F9EBEA"/>
           </a:solidFill>
-          <a:ln w="19050">
+          <a:ln w="22384">
             <a:solidFill>
               <a:srgbClr val="2C3E50"/>
             </a:solidFill>
@@ -4639,14 +4639,14 @@
           <a:p>
             <a:pPr algn="ctr">
               <a:spcBef>
-                <a:spcPts val="200"/>
-              </a:spcBef>
-              <a:spcAft>
-                <a:spcPts val="200"/>
-              </a:spcAft>
-            </a:pPr>
-            <a:r>
-              <a:rPr sz="1600" b="0">
+                <a:spcPts val="235"/>
+              </a:spcBef>
+              <a:spcAft>
+                <a:spcPts val="235"/>
+              </a:spcAft>
+            </a:pPr>
+            <a:r>
+              <a:rPr sz="1880" b="0">
                 <a:solidFill>
                   <a:srgbClr val="000000"/>
                 </a:solidFill>
@@ -4657,14 +4657,14 @@
           <a:p>
             <a:pPr algn="ctr">
               <a:spcBef>
-                <a:spcPts val="200"/>
-              </a:spcBef>
-              <a:spcAft>
-                <a:spcPts val="200"/>
-              </a:spcAft>
-            </a:pPr>
-            <a:r>
-              <a:rPr sz="1600" b="0">
+                <a:spcPts val="235"/>
+              </a:spcBef>
+              <a:spcAft>
+                <a:spcPts val="235"/>
+              </a:spcAft>
+            </a:pPr>
+            <a:r>
+              <a:rPr sz="1880" b="0">
                 <a:solidFill>
                   <a:srgbClr val="000000"/>
                 </a:solidFill>
@@ -4675,14 +4675,14 @@
           <a:p>
             <a:pPr algn="ctr">
               <a:spcBef>
-                <a:spcPts val="200"/>
-              </a:spcBef>
-              <a:spcAft>
-                <a:spcPts val="200"/>
-              </a:spcAft>
-            </a:pPr>
-            <a:r>
-              <a:rPr sz="1600" b="0">
+                <a:spcPts val="235"/>
+              </a:spcBef>
+              <a:spcAft>
+                <a:spcPts val="235"/>
+              </a:spcAft>
+            </a:pPr>
+            <a:r>
+              <a:rPr sz="1880" b="0">
                 <a:solidFill>
                   <a:srgbClr val="000000"/>
                 </a:solidFill>
@@ -4693,14 +4693,14 @@
           <a:p>
             <a:pPr algn="ctr">
               <a:spcBef>
-                <a:spcPts val="200"/>
-              </a:spcBef>
-              <a:spcAft>
-                <a:spcPts val="200"/>
-              </a:spcAft>
-            </a:pPr>
-            <a:r>
-              <a:rPr sz="1600" b="0">
+                <a:spcPts val="235"/>
+              </a:spcBef>
+              <a:spcAft>
+                <a:spcPts val="235"/>
+              </a:spcAft>
+            </a:pPr>
+            <a:r>
+              <a:rPr sz="1880" b="0">
                 <a:solidFill>
                   <a:srgbClr val="000000"/>
                 </a:solidFill>
@@ -4718,8 +4718,8 @@
         </p:nvSpPr>
         <p:spPr>
           <a:xfrm>
-            <a:off x="6300000" y="18540000"/>
-            <a:ext cx="6480000" cy="1980000"/>
+            <a:off x="7402500" y="21784500"/>
+            <a:ext cx="7614000" cy="2326500"/>
           </a:xfrm>
           <a:prstGeom prst="roundRect">
             <a:avLst>
@@ -4729,7 +4729,7 @@
           <a:solidFill>
             <a:srgbClr val="F9EBEA"/>
           </a:solidFill>
-          <a:ln w="19050">
+          <a:ln w="22384">
             <a:solidFill>
               <a:srgbClr val="2C3E50"/>
             </a:solidFill>
@@ -4755,14 +4755,14 @@
           <a:p>
             <a:pPr algn="ctr">
               <a:spcBef>
-                <a:spcPts val="200"/>
-              </a:spcBef>
-              <a:spcAft>
-                <a:spcPts val="200"/>
-              </a:spcAft>
-            </a:pPr>
-            <a:r>
-              <a:rPr sz="1600" b="0">
+                <a:spcPts val="235"/>
+              </a:spcBef>
+              <a:spcAft>
+                <a:spcPts val="235"/>
+              </a:spcAft>
+            </a:pPr>
+            <a:r>
+              <a:rPr sz="1880" b="0">
                 <a:solidFill>
                   <a:srgbClr val="000000"/>
                 </a:solidFill>
@@ -4773,14 +4773,14 @@
           <a:p>
             <a:pPr algn="ctr">
               <a:spcBef>
-                <a:spcPts val="200"/>
-              </a:spcBef>
-              <a:spcAft>
-                <a:spcPts val="200"/>
-              </a:spcAft>
-            </a:pPr>
-            <a:r>
-              <a:rPr sz="1600" b="0">
+                <a:spcPts val="235"/>
+              </a:spcBef>
+              <a:spcAft>
+                <a:spcPts val="235"/>
+              </a:spcAft>
+            </a:pPr>
+            <a:r>
+              <a:rPr sz="1880" b="0">
                 <a:solidFill>
                   <a:srgbClr val="000000"/>
                 </a:solidFill>
@@ -4791,14 +4791,14 @@
           <a:p>
             <a:pPr algn="ctr">
               <a:spcBef>
-                <a:spcPts val="200"/>
-              </a:spcBef>
-              <a:spcAft>
-                <a:spcPts val="200"/>
-              </a:spcAft>
-            </a:pPr>
-            <a:r>
-              <a:rPr sz="1600" b="0">
+                <a:spcPts val="235"/>
+              </a:spcBef>
+              <a:spcAft>
+                <a:spcPts val="235"/>
+              </a:spcAft>
+            </a:pPr>
+            <a:r>
+              <a:rPr sz="1880" b="0">
                 <a:solidFill>
                   <a:srgbClr val="000000"/>
                 </a:solidFill>
@@ -4816,8 +4816,8 @@
         </p:nvSpPr>
         <p:spPr>
           <a:xfrm>
-            <a:off x="6300000" y="20952000"/>
-            <a:ext cx="6480000" cy="3060000"/>
+            <a:off x="7402500" y="24618600"/>
+            <a:ext cx="7614000" cy="3595500"/>
           </a:xfrm>
           <a:prstGeom prst="roundRect">
             <a:avLst>
@@ -4827,7 +4827,7 @@
           <a:solidFill>
             <a:srgbClr val="EAF0FB"/>
           </a:solidFill>
-          <a:ln w="19050">
+          <a:ln w="22384">
             <a:solidFill>
               <a:srgbClr val="2C3E50"/>
             </a:solidFill>
@@ -4853,14 +4853,14 @@
           <a:p>
             <a:pPr algn="ctr">
               <a:spcBef>
-                <a:spcPts val="200"/>
-              </a:spcBef>
-              <a:spcAft>
-                <a:spcPts val="200"/>
-              </a:spcAft>
-            </a:pPr>
-            <a:r>
-              <a:rPr sz="1600" b="0">
+                <a:spcPts val="235"/>
+              </a:spcBef>
+              <a:spcAft>
+                <a:spcPts val="235"/>
+              </a:spcAft>
+            </a:pPr>
+            <a:r>
+              <a:rPr sz="1880" b="0">
                 <a:solidFill>
                   <a:srgbClr val="000000"/>
                 </a:solidFill>
@@ -4871,14 +4871,14 @@
           <a:p>
             <a:pPr algn="ctr">
               <a:spcBef>
-                <a:spcPts val="200"/>
-              </a:spcBef>
-              <a:spcAft>
-                <a:spcPts val="200"/>
-              </a:spcAft>
-            </a:pPr>
-            <a:r>
-              <a:rPr sz="1600" b="0">
+                <a:spcPts val="235"/>
+              </a:spcBef>
+              <a:spcAft>
+                <a:spcPts val="235"/>
+              </a:spcAft>
+            </a:pPr>
+            <a:r>
+              <a:rPr sz="1880" b="0">
                 <a:solidFill>
                   <a:srgbClr val="000000"/>
                 </a:solidFill>
@@ -4889,14 +4889,14 @@
           <a:p>
             <a:pPr algn="ctr">
               <a:spcBef>
-                <a:spcPts val="200"/>
-              </a:spcBef>
-              <a:spcAft>
-                <a:spcPts val="200"/>
-              </a:spcAft>
-            </a:pPr>
-            <a:r>
-              <a:rPr sz="1600" b="0">
+                <a:spcPts val="235"/>
+              </a:spcBef>
+              <a:spcAft>
+                <a:spcPts val="235"/>
+              </a:spcAft>
+            </a:pPr>
+            <a:r>
+              <a:rPr sz="1880" b="0">
                 <a:solidFill>
                   <a:srgbClr val="000000"/>
                 </a:solidFill>
@@ -4907,14 +4907,14 @@
           <a:p>
             <a:pPr algn="ctr">
               <a:spcBef>
-                <a:spcPts val="200"/>
-              </a:spcBef>
-              <a:spcAft>
-                <a:spcPts val="200"/>
-              </a:spcAft>
-            </a:pPr>
-            <a:r>
-              <a:rPr sz="1600" b="0">
+                <a:spcPts val="235"/>
+              </a:spcBef>
+              <a:spcAft>
+                <a:spcPts val="235"/>
+              </a:spcAft>
+            </a:pPr>
+            <a:r>
+              <a:rPr sz="1880" b="0">
                 <a:solidFill>
                   <a:srgbClr val="000000"/>
                 </a:solidFill>
@@ -4925,14 +4925,14 @@
           <a:p>
             <a:pPr algn="ctr">
               <a:spcBef>
-                <a:spcPts val="200"/>
-              </a:spcBef>
-              <a:spcAft>
-                <a:spcPts val="200"/>
-              </a:spcAft>
-            </a:pPr>
-            <a:r>
-              <a:rPr sz="1600" b="0">
+                <a:spcPts val="235"/>
+              </a:spcBef>
+              <a:spcAft>
+                <a:spcPts val="235"/>
+              </a:spcAft>
+            </a:pPr>
+            <a:r>
+              <a:rPr sz="1880" b="0">
                 <a:solidFill>
                   <a:srgbClr val="000000"/>
                 </a:solidFill>
@@ -4943,14 +4943,14 @@
           <a:p>
             <a:pPr algn="ctr">
               <a:spcBef>
-                <a:spcPts val="200"/>
-              </a:spcBef>
-              <a:spcAft>
-                <a:spcPts val="200"/>
-              </a:spcAft>
-            </a:pPr>
-            <a:r>
-              <a:rPr sz="1600" b="0">
+                <a:spcPts val="235"/>
+              </a:spcBef>
+              <a:spcAft>
+                <a:spcPts val="235"/>
+              </a:spcAft>
+            </a:pPr>
+            <a:r>
+              <a:rPr sz="1880" b="0">
                 <a:solidFill>
                   <a:srgbClr val="000000"/>
                 </a:solidFill>
@@ -4968,13 +4968,13 @@
         </p:nvCxnSpPr>
         <p:spPr>
           <a:xfrm>
-            <a:off x="9540000" y="6120000"/>
-            <a:ext cx="0" cy="432000"/>
+            <a:off x="11209500" y="7191000"/>
+            <a:ext cx="0" cy="507600"/>
           </a:xfrm>
           <a:prstGeom prst="line">
             <a:avLst/>
           </a:prstGeom>
-          <a:ln w="27940">
+          <a:ln w="32830">
             <a:solidFill>
               <a:srgbClr val="2C3E50"/>
             </a:solidFill>
@@ -5005,13 +5005,13 @@
         </p:nvCxnSpPr>
         <p:spPr>
           <a:xfrm>
-            <a:off x="9540000" y="10512000"/>
-            <a:ext cx="0" cy="432000"/>
+            <a:off x="11209500" y="12351600"/>
+            <a:ext cx="0" cy="507600"/>
           </a:xfrm>
           <a:prstGeom prst="line">
             <a:avLst/>
           </a:prstGeom>
-          <a:ln w="27940">
+          <a:ln w="32830">
             <a:solidFill>
               <a:srgbClr val="2C3E50"/>
             </a:solidFill>
@@ -5042,13 +5042,13 @@
         </p:nvCxnSpPr>
         <p:spPr>
           <a:xfrm>
-            <a:off x="9540000" y="12924000"/>
-            <a:ext cx="0" cy="432000"/>
+            <a:off x="11209500" y="15185700"/>
+            <a:ext cx="0" cy="507600"/>
           </a:xfrm>
           <a:prstGeom prst="line">
             <a:avLst/>
           </a:prstGeom>
-          <a:ln w="27940">
+          <a:ln w="32830">
             <a:solidFill>
               <a:srgbClr val="2C3E50"/>
             </a:solidFill>
@@ -5079,13 +5079,13 @@
         </p:nvCxnSpPr>
         <p:spPr>
           <a:xfrm>
-            <a:off x="9540000" y="15516000"/>
-            <a:ext cx="0" cy="432000"/>
+            <a:off x="11209500" y="18231300"/>
+            <a:ext cx="0" cy="507600"/>
           </a:xfrm>
           <a:prstGeom prst="line">
             <a:avLst/>
           </a:prstGeom>
-          <a:ln w="27940">
+          <a:ln w="32830">
             <a:solidFill>
               <a:srgbClr val="2C3E50"/>
             </a:solidFill>
@@ -5116,13 +5116,13 @@
         </p:nvCxnSpPr>
         <p:spPr>
           <a:xfrm>
-            <a:off x="9540000" y="18108000"/>
-            <a:ext cx="0" cy="432000"/>
+            <a:off x="11209500" y="21276900"/>
+            <a:ext cx="0" cy="507600"/>
           </a:xfrm>
           <a:prstGeom prst="line">
             <a:avLst/>
           </a:prstGeom>
-          <a:ln w="27940">
+          <a:ln w="32830">
             <a:solidFill>
               <a:srgbClr val="2C3E50"/>
             </a:solidFill>
@@ -5153,13 +5153,13 @@
         </p:nvCxnSpPr>
         <p:spPr>
           <a:xfrm>
-            <a:off x="9540000" y="20520000"/>
-            <a:ext cx="0" cy="432000"/>
+            <a:off x="11209500" y="24111000"/>
+            <a:ext cx="0" cy="507600"/>
           </a:xfrm>
           <a:prstGeom prst="line">
             <a:avLst/>
           </a:prstGeom>
-          <a:ln w="27940">
+          <a:ln w="32830">
             <a:solidFill>
               <a:srgbClr val="2C3E50"/>
             </a:solidFill>
@@ -5190,8 +5190,8 @@
         </p:nvSpPr>
         <p:spPr>
           <a:xfrm>
-            <a:off x="13500000" y="3420000"/>
-            <a:ext cx="3780000" cy="1980000"/>
+            <a:off x="15862500" y="4018500"/>
+            <a:ext cx="4441500" cy="2326500"/>
           </a:xfrm>
           <a:prstGeom prst="roundRect">
             <a:avLst>
@@ -5201,7 +5201,7 @@
           <a:solidFill>
             <a:srgbClr val="EBF5FB"/>
           </a:solidFill>
-          <a:ln w="19050">
+          <a:ln w="22384">
             <a:solidFill>
               <a:srgbClr val="2C3E50"/>
             </a:solidFill>
@@ -5227,14 +5227,14 @@
           <a:p>
             <a:pPr algn="ctr">
               <a:spcBef>
-                <a:spcPts val="200"/>
-              </a:spcBef>
-              <a:spcAft>
-                <a:spcPts val="200"/>
-              </a:spcAft>
-            </a:pPr>
-            <a:r>
-              <a:rPr sz="1600" b="0">
+                <a:spcPts val="235"/>
+              </a:spcBef>
+              <a:spcAft>
+                <a:spcPts val="235"/>
+              </a:spcAft>
+            </a:pPr>
+            <a:r>
+              <a:rPr sz="1880" b="0">
                 <a:solidFill>
                   <a:srgbClr val="000000"/>
                 </a:solidFill>
@@ -5245,14 +5245,14 @@
           <a:p>
             <a:pPr algn="ctr">
               <a:spcBef>
-                <a:spcPts val="200"/>
-              </a:spcBef>
-              <a:spcAft>
-                <a:spcPts val="200"/>
-              </a:spcAft>
-            </a:pPr>
-            <a:r>
-              <a:rPr sz="1600" b="0">
+                <a:spcPts val="235"/>
+              </a:spcBef>
+              <a:spcAft>
+                <a:spcPts val="235"/>
+              </a:spcAft>
+            </a:pPr>
+            <a:r>
+              <a:rPr sz="1880" b="0">
                 <a:solidFill>
                   <a:srgbClr val="000000"/>
                 </a:solidFill>
@@ -5270,8 +5270,8 @@
         </p:nvSpPr>
         <p:spPr>
           <a:xfrm>
-            <a:off x="13500000" y="5760000"/>
-            <a:ext cx="3780000" cy="1980000"/>
+            <a:off x="15862500" y="6768000"/>
+            <a:ext cx="4441500" cy="2326500"/>
           </a:xfrm>
           <a:prstGeom prst="roundRect">
             <a:avLst>
@@ -5281,7 +5281,7 @@
           <a:solidFill>
             <a:srgbClr val="EBF5FB"/>
           </a:solidFill>
-          <a:ln w="19050">
+          <a:ln w="22384">
             <a:solidFill>
               <a:srgbClr val="2C3E50"/>
             </a:solidFill>
@@ -5307,14 +5307,14 @@
           <a:p>
             <a:pPr algn="ctr">
               <a:spcBef>
-                <a:spcPts val="200"/>
-              </a:spcBef>
-              <a:spcAft>
-                <a:spcPts val="200"/>
-              </a:spcAft>
-            </a:pPr>
-            <a:r>
-              <a:rPr sz="1600" b="0">
+                <a:spcPts val="235"/>
+              </a:spcBef>
+              <a:spcAft>
+                <a:spcPts val="235"/>
+              </a:spcAft>
+            </a:pPr>
+            <a:r>
+              <a:rPr sz="1880" b="0">
                 <a:solidFill>
                   <a:srgbClr val="000000"/>
                 </a:solidFill>
@@ -5325,14 +5325,14 @@
           <a:p>
             <a:pPr algn="ctr">
               <a:spcBef>
-                <a:spcPts val="200"/>
-              </a:spcBef>
-              <a:spcAft>
-                <a:spcPts val="200"/>
-              </a:spcAft>
-            </a:pPr>
-            <a:r>
-              <a:rPr sz="1600" b="0">
+                <a:spcPts val="235"/>
+              </a:spcBef>
+              <a:spcAft>
+                <a:spcPts val="235"/>
+              </a:spcAft>
+            </a:pPr>
+            <a:r>
+              <a:rPr sz="1880" b="0">
                 <a:solidFill>
                   <a:srgbClr val="000000"/>
                 </a:solidFill>
@@ -5350,8 +5350,8 @@
         </p:nvSpPr>
         <p:spPr>
           <a:xfrm>
-            <a:off x="13500000" y="8100000"/>
-            <a:ext cx="3780000" cy="1980000"/>
+            <a:off x="15862500" y="9517500"/>
+            <a:ext cx="4441500" cy="2326500"/>
           </a:xfrm>
           <a:prstGeom prst="roundRect">
             <a:avLst>
@@ -5361,7 +5361,7 @@
           <a:solidFill>
             <a:srgbClr val="EBF5FB"/>
           </a:solidFill>
-          <a:ln w="19050">
+          <a:ln w="22384">
             <a:solidFill>
               <a:srgbClr val="2C3E50"/>
             </a:solidFill>
@@ -5387,14 +5387,14 @@
           <a:p>
             <a:pPr algn="ctr">
               <a:spcBef>
-                <a:spcPts val="200"/>
-              </a:spcBef>
-              <a:spcAft>
-                <a:spcPts val="200"/>
-              </a:spcAft>
-            </a:pPr>
-            <a:r>
-              <a:rPr sz="1600" b="0">
+                <a:spcPts val="235"/>
+              </a:spcBef>
+              <a:spcAft>
+                <a:spcPts val="235"/>
+              </a:spcAft>
+            </a:pPr>
+            <a:r>
+              <a:rPr sz="1880" b="0">
                 <a:solidFill>
                   <a:srgbClr val="000000"/>
                 </a:solidFill>
@@ -5405,14 +5405,14 @@
           <a:p>
             <a:pPr algn="ctr">
               <a:spcBef>
-                <a:spcPts val="200"/>
-              </a:spcBef>
-              <a:spcAft>
-                <a:spcPts val="200"/>
-              </a:spcAft>
-            </a:pPr>
-            <a:r>
-              <a:rPr sz="1600" b="0">
+                <a:spcPts val="235"/>
+              </a:spcBef>
+              <a:spcAft>
+                <a:spcPts val="235"/>
+              </a:spcAft>
+            </a:pPr>
+            <a:r>
+              <a:rPr sz="1880" b="0">
                 <a:solidFill>
                   <a:srgbClr val="000000"/>
                 </a:solidFill>
@@ -5430,8 +5430,8 @@
         </p:nvSpPr>
         <p:spPr>
           <a:xfrm>
-            <a:off x="13500000" y="10440000"/>
-            <a:ext cx="3780000" cy="1980000"/>
+            <a:off x="15862500" y="12267000"/>
+            <a:ext cx="4441500" cy="2326500"/>
           </a:xfrm>
           <a:prstGeom prst="roundRect">
             <a:avLst>
@@ -5441,7 +5441,7 @@
           <a:solidFill>
             <a:srgbClr val="EBF5FB"/>
           </a:solidFill>
-          <a:ln w="19050">
+          <a:ln w="22384">
             <a:solidFill>
               <a:srgbClr val="2C3E50"/>
             </a:solidFill>
@@ -5467,14 +5467,14 @@
           <a:p>
             <a:pPr algn="ctr">
               <a:spcBef>
-                <a:spcPts val="200"/>
-              </a:spcBef>
-              <a:spcAft>
-                <a:spcPts val="200"/>
-              </a:spcAft>
-            </a:pPr>
-            <a:r>
-              <a:rPr sz="1600" b="0">
+                <a:spcPts val="235"/>
+              </a:spcBef>
+              <a:spcAft>
+                <a:spcPts val="235"/>
+              </a:spcAft>
+            </a:pPr>
+            <a:r>
+              <a:rPr sz="1880" b="0">
                 <a:solidFill>
                   <a:srgbClr val="000000"/>
                 </a:solidFill>
@@ -5485,14 +5485,14 @@
           <a:p>
             <a:pPr algn="ctr">
               <a:spcBef>
-                <a:spcPts val="200"/>
-              </a:spcBef>
-              <a:spcAft>
-                <a:spcPts val="200"/>
-              </a:spcAft>
-            </a:pPr>
-            <a:r>
-              <a:rPr sz="1600" b="0">
+                <a:spcPts val="235"/>
+              </a:spcBef>
+              <a:spcAft>
+                <a:spcPts val="235"/>
+              </a:spcAft>
+            </a:pPr>
+            <a:r>
+              <a:rPr sz="1880" b="0">
                 <a:solidFill>
                   <a:srgbClr val="000000"/>
                 </a:solidFill>
@@ -5510,8 +5510,8 @@
         </p:nvSpPr>
         <p:spPr>
           <a:xfrm>
-            <a:off x="13500000" y="12780000"/>
-            <a:ext cx="3780000" cy="1980000"/>
+            <a:off x="15862500" y="15016500"/>
+            <a:ext cx="4441500" cy="2326500"/>
           </a:xfrm>
           <a:prstGeom prst="roundRect">
             <a:avLst>
@@ -5521,7 +5521,7 @@
           <a:solidFill>
             <a:srgbClr val="EBF5FB"/>
           </a:solidFill>
-          <a:ln w="19050">
+          <a:ln w="22384">
             <a:solidFill>
               <a:srgbClr val="2C3E50"/>
             </a:solidFill>
@@ -5547,14 +5547,14 @@
           <a:p>
             <a:pPr algn="ctr">
               <a:spcBef>
-                <a:spcPts val="200"/>
-              </a:spcBef>
-              <a:spcAft>
-                <a:spcPts val="200"/>
-              </a:spcAft>
-            </a:pPr>
-            <a:r>
-              <a:rPr sz="1600" b="0">
+                <a:spcPts val="235"/>
+              </a:spcBef>
+              <a:spcAft>
+                <a:spcPts val="235"/>
+              </a:spcAft>
+            </a:pPr>
+            <a:r>
+              <a:rPr sz="1880" b="0">
                 <a:solidFill>
                   <a:srgbClr val="000000"/>
                 </a:solidFill>
@@ -5565,14 +5565,14 @@
           <a:p>
             <a:pPr algn="ctr">
               <a:spcBef>
-                <a:spcPts val="200"/>
-              </a:spcBef>
-              <a:spcAft>
-                <a:spcPts val="200"/>
-              </a:spcAft>
-            </a:pPr>
-            <a:r>
-              <a:rPr sz="1600" b="0">
+                <a:spcPts val="235"/>
+              </a:spcBef>
+              <a:spcAft>
+                <a:spcPts val="235"/>
+              </a:spcAft>
+            </a:pPr>
+            <a:r>
+              <a:rPr sz="1880" b="0">
                 <a:solidFill>
                   <a:srgbClr val="000000"/>
                 </a:solidFill>
@@ -5590,8 +5590,8 @@
         </p:nvSpPr>
         <p:spPr>
           <a:xfrm>
-            <a:off x="13500000" y="15120000"/>
-            <a:ext cx="3780000" cy="1980000"/>
+            <a:off x="15862500" y="17766000"/>
+            <a:ext cx="4441500" cy="2326500"/>
           </a:xfrm>
           <a:prstGeom prst="roundRect">
             <a:avLst>
@@ -5601,7 +5601,7 @@
           <a:solidFill>
             <a:srgbClr val="EBF5FB"/>
           </a:solidFill>
-          <a:ln w="19050">
+          <a:ln w="22384">
             <a:solidFill>
               <a:srgbClr val="2C3E50"/>
             </a:solidFill>
@@ -5627,14 +5627,14 @@
           <a:p>
             <a:pPr algn="ctr">
               <a:spcBef>
-                <a:spcPts val="200"/>
-              </a:spcBef>
-              <a:spcAft>
-                <a:spcPts val="200"/>
-              </a:spcAft>
-            </a:pPr>
-            <a:r>
-              <a:rPr sz="1600" b="0">
+                <a:spcPts val="235"/>
+              </a:spcBef>
+              <a:spcAft>
+                <a:spcPts val="235"/>
+              </a:spcAft>
+            </a:pPr>
+            <a:r>
+              <a:rPr sz="1880" b="0">
                 <a:solidFill>
                   <a:srgbClr val="000000"/>
                 </a:solidFill>
@@ -5645,14 +5645,14 @@
           <a:p>
             <a:pPr algn="ctr">
               <a:spcBef>
-                <a:spcPts val="200"/>
-              </a:spcBef>
-              <a:spcAft>
-                <a:spcPts val="200"/>
-              </a:spcAft>
-            </a:pPr>
-            <a:r>
-              <a:rPr sz="1600" b="0">
+                <a:spcPts val="235"/>
+              </a:spcBef>
+              <a:spcAft>
+                <a:spcPts val="235"/>
+              </a:spcAft>
+            </a:pPr>
+            <a:r>
+              <a:rPr sz="1880" b="0">
                 <a:solidFill>
                   <a:srgbClr val="000000"/>
                 </a:solidFill>
@@ -5670,13 +5670,13 @@
         </p:nvCxnSpPr>
         <p:spPr>
           <a:xfrm>
-            <a:off x="5580000" y="4410000"/>
-            <a:ext cx="720000" cy="1223999"/>
+            <a:off x="6556500" y="5181750"/>
+            <a:ext cx="846000" cy="1438199"/>
           </a:xfrm>
           <a:prstGeom prst="line">
             <a:avLst/>
           </a:prstGeom>
-          <a:ln w="22860">
+          <a:ln w="26860">
             <a:solidFill>
               <a:srgbClr val="5D6D7E"/>
             </a:solidFill>
@@ -5707,13 +5707,13 @@
         </p:nvCxnSpPr>
         <p:spPr>
           <a:xfrm flipV="1">
-            <a:off x="5580000" y="4905000"/>
-            <a:ext cx="720000" cy="1773000"/>
+            <a:off x="6556500" y="5763375"/>
+            <a:ext cx="846000" cy="2083275"/>
           </a:xfrm>
           <a:prstGeom prst="line">
             <a:avLst/>
           </a:prstGeom>
-          <a:ln w="22860">
+          <a:ln w="26860">
             <a:solidFill>
               <a:srgbClr val="5D6D7E"/>
             </a:solidFill>
@@ -5744,13 +5744,13 @@
         </p:nvCxnSpPr>
         <p:spPr>
           <a:xfrm>
-            <a:off x="5580000" y="9036000"/>
-            <a:ext cx="720000" cy="763200"/>
+            <a:off x="6556500" y="10617300"/>
+            <a:ext cx="846000" cy="896760"/>
           </a:xfrm>
           <a:prstGeom prst="line">
             <a:avLst/>
           </a:prstGeom>
-          <a:ln w="22860">
+          <a:ln w="26860">
             <a:solidFill>
               <a:srgbClr val="5D6D7E"/>
             </a:solidFill>
@@ -5781,13 +5781,13 @@
         </p:nvCxnSpPr>
         <p:spPr>
           <a:xfrm flipV="1">
-            <a:off x="5580000" y="8848800"/>
-            <a:ext cx="720000" cy="2545200"/>
+            <a:off x="6556500" y="10397340"/>
+            <a:ext cx="846000" cy="2990610"/>
           </a:xfrm>
           <a:prstGeom prst="line">
             <a:avLst/>
           </a:prstGeom>
-          <a:ln w="22860">
+          <a:ln w="26860">
             <a:solidFill>
               <a:srgbClr val="5D6D7E"/>
             </a:solidFill>
@@ -5818,13 +5818,13 @@
         </p:nvCxnSpPr>
         <p:spPr>
           <a:xfrm flipV="1">
-            <a:off x="5580000" y="7898399"/>
-            <a:ext cx="720000" cy="5763601"/>
+            <a:off x="6556500" y="9280619"/>
+            <a:ext cx="846000" cy="6772231"/>
           </a:xfrm>
           <a:prstGeom prst="line">
             <a:avLst/>
           </a:prstGeom>
-          <a:ln w="22860">
+          <a:ln w="26860">
             <a:solidFill>
               <a:srgbClr val="5D6D7E"/>
             </a:solidFill>
@@ -5855,13 +5855,13 @@
         </p:nvCxnSpPr>
         <p:spPr>
           <a:xfrm flipV="1">
-            <a:off x="5580000" y="14436000"/>
-            <a:ext cx="720000" cy="3942000"/>
+            <a:off x="6556500" y="16962300"/>
+            <a:ext cx="846000" cy="4631850"/>
           </a:xfrm>
           <a:prstGeom prst="line">
             <a:avLst/>
           </a:prstGeom>
-          <a:ln w="22860">
+          <a:ln w="26860">
             <a:solidFill>
               <a:srgbClr val="5D6D7E"/>
             </a:solidFill>
@@ -5892,13 +5892,13 @@
         </p:nvCxnSpPr>
         <p:spPr>
           <a:xfrm flipV="1">
-            <a:off x="5580000" y="7027200"/>
-            <a:ext cx="720000" cy="8992800"/>
+            <a:off x="6556500" y="8256960"/>
+            <a:ext cx="846000" cy="10566540"/>
           </a:xfrm>
           <a:prstGeom prst="line">
             <a:avLst/>
           </a:prstGeom>
-          <a:ln w="25400">
+          <a:ln w="29845">
             <a:solidFill>
               <a:srgbClr val="C0392B"/>
             </a:solidFill>
@@ -5930,8 +5930,8 @@
         </p:nvSpPr>
         <p:spPr>
           <a:xfrm>
-            <a:off x="4500000" y="6487200"/>
-            <a:ext cx="1620000" cy="540000"/>
+            <a:off x="5287500" y="7622460"/>
+            <a:ext cx="1903500" cy="634500"/>
           </a:xfrm>
           <a:prstGeom prst="rect">
             <a:avLst/>
@@ -5946,7 +5946,7 @@
           <a:p>
             <a:pPr algn="ctr"/>
             <a:r>
-              <a:rPr sz="1400" i="1">
+              <a:rPr sz="1645" i="1">
                 <a:solidFill>
                   <a:srgbClr val="C0392B"/>
                 </a:solidFill>
@@ -5964,13 +5964,13 @@
         </p:nvCxnSpPr>
         <p:spPr>
           <a:xfrm flipV="1">
-            <a:off x="12780000" y="4410000"/>
-            <a:ext cx="720000" cy="6102000"/>
+            <a:off x="15016500" y="5181750"/>
+            <a:ext cx="846000" cy="7169850"/>
           </a:xfrm>
           <a:prstGeom prst="line">
             <a:avLst/>
           </a:prstGeom>
-          <a:ln w="22860">
+          <a:ln w="26860">
             <a:solidFill>
               <a:srgbClr val="5D6D7E"/>
             </a:solidFill>
@@ -6001,13 +6001,13 @@
         </p:nvCxnSpPr>
         <p:spPr>
           <a:xfrm flipV="1">
-            <a:off x="12780000" y="6750000"/>
-            <a:ext cx="720000" cy="7686000"/>
+            <a:off x="15016500" y="7931250"/>
+            <a:ext cx="846000" cy="9031050"/>
           </a:xfrm>
           <a:prstGeom prst="line">
             <a:avLst/>
           </a:prstGeom>
-          <a:ln w="22860">
+          <a:ln w="26860">
             <a:solidFill>
               <a:srgbClr val="5D6D7E"/>
             </a:solidFill>
@@ -6038,13 +6038,13 @@
         </p:nvCxnSpPr>
         <p:spPr>
           <a:xfrm flipV="1">
-            <a:off x="12780000" y="9090000"/>
-            <a:ext cx="720000" cy="14922000"/>
+            <a:off x="15016500" y="10680750"/>
+            <a:ext cx="846000" cy="17533350"/>
           </a:xfrm>
           <a:prstGeom prst="line">
             <a:avLst/>
           </a:prstGeom>
-          <a:ln w="22860">
+          <a:ln w="26860">
             <a:solidFill>
               <a:srgbClr val="5D6D7E"/>
             </a:solidFill>
@@ -6075,13 +6075,13 @@
         </p:nvCxnSpPr>
         <p:spPr>
           <a:xfrm flipV="1">
-            <a:off x="12780000" y="11430000"/>
-            <a:ext cx="720000" cy="11664000"/>
+            <a:off x="15016500" y="13430250"/>
+            <a:ext cx="846000" cy="13705200"/>
           </a:xfrm>
           <a:prstGeom prst="line">
             <a:avLst/>
           </a:prstGeom>
-          <a:ln w="22860">
+          <a:ln w="26860">
             <a:solidFill>
               <a:srgbClr val="5D6D7E"/>
             </a:solidFill>
@@ -6112,13 +6112,13 @@
         </p:nvCxnSpPr>
         <p:spPr>
           <a:xfrm flipV="1">
-            <a:off x="12780000" y="13770000"/>
-            <a:ext cx="720000" cy="8406000"/>
+            <a:off x="15016500" y="16179750"/>
+            <a:ext cx="846000" cy="9877050"/>
           </a:xfrm>
           <a:prstGeom prst="line">
             <a:avLst/>
           </a:prstGeom>
-          <a:ln w="22860">
+          <a:ln w="26860">
             <a:solidFill>
               <a:srgbClr val="5D6D7E"/>
             </a:solidFill>
@@ -6149,13 +6149,13 @@
         </p:nvCxnSpPr>
         <p:spPr>
           <a:xfrm flipV="1">
-            <a:off x="12780000" y="16110000"/>
-            <a:ext cx="720000" cy="4842000"/>
+            <a:off x="15016500" y="18929250"/>
+            <a:ext cx="846000" cy="5689350"/>
           </a:xfrm>
           <a:prstGeom prst="line">
             <a:avLst/>
           </a:prstGeom>
-          <a:ln w="22860">
+          <a:ln w="26860">
             <a:solidFill>
               <a:srgbClr val="5D6D7E"/>
             </a:solidFill>
@@ -6186,8 +6186,8 @@
         </p:nvSpPr>
         <p:spPr>
           <a:xfrm>
-            <a:off x="360000" y="24912000"/>
-            <a:ext cx="2342571" cy="1007999"/>
+            <a:off x="423000" y="29271600"/>
+            <a:ext cx="2752521" cy="1184399"/>
           </a:xfrm>
           <a:prstGeom prst="roundRect">
             <a:avLst>
@@ -6197,7 +6197,7 @@
           <a:solidFill>
             <a:srgbClr val="D6EAF8"/>
           </a:solidFill>
-          <a:ln w="12700">
+          <a:ln w="14922">
             <a:solidFill>
               <a:srgbClr val="2C3E50"/>
             </a:solidFill>
@@ -6223,14 +6223,14 @@
           <a:p>
             <a:pPr algn="ctr">
               <a:spcBef>
-                <a:spcPts val="200"/>
-              </a:spcBef>
-              <a:spcAft>
-                <a:spcPts val="200"/>
-              </a:spcAft>
-            </a:pPr>
-            <a:r>
-              <a:rPr sz="1400" b="0">
+                <a:spcPts val="235"/>
+              </a:spcBef>
+              <a:spcAft>
+                <a:spcPts val="235"/>
+              </a:spcAft>
+            </a:pPr>
+            <a:r>
+              <a:rPr sz="1645" b="0">
                 <a:solidFill>
                   <a:srgbClr val="000000"/>
                 </a:solidFill>
@@ -6248,8 +6248,8 @@
         </p:nvSpPr>
         <p:spPr>
           <a:xfrm>
-            <a:off x="2828571" y="24912000"/>
-            <a:ext cx="2342571" cy="1007999"/>
+            <a:off x="3323571" y="29271600"/>
+            <a:ext cx="2752521" cy="1184399"/>
           </a:xfrm>
           <a:prstGeom prst="roundRect">
             <a:avLst>
@@ -6259,7 +6259,7 @@
           <a:solidFill>
             <a:srgbClr val="D5F5E3"/>
           </a:solidFill>
-          <a:ln w="12700">
+          <a:ln w="14922">
             <a:solidFill>
               <a:srgbClr val="2C3E50"/>
             </a:solidFill>
@@ -6285,14 +6285,14 @@
           <a:p>
             <a:pPr algn="ctr">
               <a:spcBef>
-                <a:spcPts val="200"/>
-              </a:spcBef>
-              <a:spcAft>
-                <a:spcPts val="200"/>
-              </a:spcAft>
-            </a:pPr>
-            <a:r>
-              <a:rPr sz="1400" b="0">
+                <a:spcPts val="235"/>
+              </a:spcBef>
+              <a:spcAft>
+                <a:spcPts val="235"/>
+              </a:spcAft>
+            </a:pPr>
+            <a:r>
+              <a:rPr sz="1645" b="0">
                 <a:solidFill>
                   <a:srgbClr val="000000"/>
                 </a:solidFill>
@@ -6310,8 +6310,8 @@
         </p:nvSpPr>
         <p:spPr>
           <a:xfrm>
-            <a:off x="5297142" y="24912000"/>
-            <a:ext cx="2342571" cy="1007999"/>
+            <a:off x="6224142" y="29271600"/>
+            <a:ext cx="2752521" cy="1184399"/>
           </a:xfrm>
           <a:prstGeom prst="roundRect">
             <a:avLst>
@@ -6321,7 +6321,7 @@
           <a:solidFill>
             <a:srgbClr val="FDEBD0"/>
           </a:solidFill>
-          <a:ln w="12700">
+          <a:ln w="14922">
             <a:solidFill>
               <a:srgbClr val="2C3E50"/>
             </a:solidFill>
@@ -6347,14 +6347,14 @@
           <a:p>
             <a:pPr algn="ctr">
               <a:spcBef>
-                <a:spcPts val="200"/>
-              </a:spcBef>
-              <a:spcAft>
-                <a:spcPts val="200"/>
-              </a:spcAft>
-            </a:pPr>
-            <a:r>
-              <a:rPr sz="1400" b="0">
+                <a:spcPts val="235"/>
+              </a:spcBef>
+              <a:spcAft>
+                <a:spcPts val="235"/>
+              </a:spcAft>
+            </a:pPr>
+            <a:r>
+              <a:rPr sz="1645" b="0">
                 <a:solidFill>
                   <a:srgbClr val="000000"/>
                 </a:solidFill>
@@ -6372,8 +6372,8 @@
         </p:nvSpPr>
         <p:spPr>
           <a:xfrm>
-            <a:off x="7765714" y="24912000"/>
-            <a:ext cx="2342571" cy="1007999"/>
+            <a:off x="9124714" y="29271600"/>
+            <a:ext cx="2752521" cy="1184399"/>
           </a:xfrm>
           <a:prstGeom prst="roundRect">
             <a:avLst>
@@ -6383,7 +6383,7 @@
           <a:solidFill>
             <a:srgbClr val="F9EBEA"/>
           </a:solidFill>
-          <a:ln w="12700">
+          <a:ln w="14922">
             <a:solidFill>
               <a:srgbClr val="2C3E50"/>
             </a:solidFill>
@@ -6409,14 +6409,14 @@
           <a:p>
             <a:pPr algn="ctr">
               <a:spcBef>
-                <a:spcPts val="200"/>
-              </a:spcBef>
-              <a:spcAft>
-                <a:spcPts val="200"/>
-              </a:spcAft>
-            </a:pPr>
-            <a:r>
-              <a:rPr sz="1400" b="0">
+                <a:spcPts val="235"/>
+              </a:spcBef>
+              <a:spcAft>
+                <a:spcPts val="235"/>
+              </a:spcAft>
+            </a:pPr>
+            <a:r>
+              <a:rPr sz="1645" b="0">
                 <a:solidFill>
                   <a:srgbClr val="000000"/>
                 </a:solidFill>
@@ -6434,8 +6434,8 @@
         </p:nvSpPr>
         <p:spPr>
           <a:xfrm>
-            <a:off x="10234285" y="24912000"/>
-            <a:ext cx="2342571" cy="1007999"/>
+            <a:off x="12025285" y="29271600"/>
+            <a:ext cx="2752521" cy="1184399"/>
           </a:xfrm>
           <a:prstGeom prst="roundRect">
             <a:avLst>
@@ -6445,7 +6445,7 @@
           <a:solidFill>
             <a:srgbClr val="EAF0FB"/>
           </a:solidFill>
-          <a:ln w="12700">
+          <a:ln w="14922">
             <a:solidFill>
               <a:srgbClr val="2C3E50"/>
             </a:solidFill>
@@ -6471,14 +6471,14 @@
           <a:p>
             <a:pPr algn="ctr">
               <a:spcBef>
-                <a:spcPts val="200"/>
-              </a:spcBef>
-              <a:spcAft>
-                <a:spcPts val="200"/>
-              </a:spcAft>
-            </a:pPr>
-            <a:r>
-              <a:rPr sz="1400" b="0">
+                <a:spcPts val="235"/>
+              </a:spcBef>
+              <a:spcAft>
+                <a:spcPts val="235"/>
+              </a:spcAft>
+            </a:pPr>
+            <a:r>
+              <a:rPr sz="1645" b="0">
                 <a:solidFill>
                   <a:srgbClr val="000000"/>
                 </a:solidFill>
@@ -6496,8 +6496,8 @@
         </p:nvSpPr>
         <p:spPr>
           <a:xfrm>
-            <a:off x="12702857" y="24912000"/>
-            <a:ext cx="2342571" cy="1007999"/>
+            <a:off x="14925857" y="29271600"/>
+            <a:ext cx="2752521" cy="1184399"/>
           </a:xfrm>
           <a:prstGeom prst="roundRect">
             <a:avLst>
@@ -6507,7 +6507,7 @@
           <a:solidFill>
             <a:srgbClr val="EBF5FB"/>
           </a:solidFill>
-          <a:ln w="12700">
+          <a:ln w="14922">
             <a:solidFill>
               <a:srgbClr val="2C3E50"/>
             </a:solidFill>
@@ -6533,14 +6533,14 @@
           <a:p>
             <a:pPr algn="ctr">
               <a:spcBef>
-                <a:spcPts val="200"/>
-              </a:spcBef>
-              <a:spcAft>
-                <a:spcPts val="200"/>
-              </a:spcAft>
-            </a:pPr>
-            <a:r>
-              <a:rPr sz="1400" b="0">
+                <a:spcPts val="235"/>
+              </a:spcBef>
+              <a:spcAft>
+                <a:spcPts val="235"/>
+              </a:spcAft>
+            </a:pPr>
+            <a:r>
+              <a:rPr sz="1645" b="0">
                 <a:solidFill>
                   <a:srgbClr val="000000"/>
                 </a:solidFill>
@@ -6558,8 +6558,8 @@
         </p:nvSpPr>
         <p:spPr>
           <a:xfrm>
-            <a:off x="15171428" y="24912000"/>
-            <a:ext cx="2342571" cy="1007999"/>
+            <a:off x="17826428" y="29271600"/>
+            <a:ext cx="2752521" cy="1184399"/>
           </a:xfrm>
           <a:prstGeom prst="roundRect">
             <a:avLst>
@@ -6569,7 +6569,7 @@
           <a:solidFill>
             <a:srgbClr val="FDEDEC"/>
           </a:solidFill>
-          <a:ln w="12700">
+          <a:ln w="14922">
             <a:solidFill>
               <a:srgbClr val="2C3E50"/>
             </a:solidFill>
@@ -6595,14 +6595,14 @@
           <a:p>
             <a:pPr algn="ctr">
               <a:spcBef>
-                <a:spcPts val="200"/>
-              </a:spcBef>
-              <a:spcAft>
-                <a:spcPts val="200"/>
-              </a:spcAft>
-            </a:pPr>
-            <a:r>
-              <a:rPr sz="1400" b="0">
+                <a:spcPts val="235"/>
+              </a:spcBef>
+              <a:spcAft>
+                <a:spcPts val="235"/>
+              </a:spcAft>
+            </a:pPr>
+            <a:r>
+              <a:rPr sz="1645" b="0">
                 <a:solidFill>
                   <a:srgbClr val="000000"/>
                 </a:solidFill>

</xml_diff>